<commit_message>
Label Module 5 deck figures as stand-in reference runs
Every Part 2 caption or note that quotes a notebook number now says it
comes from the reference run on the deterministic stand-in and that the
live Claude run varies and reports real tokens. Deck 1 gains a live-demo
row in the three-ways table; deck 2's engine slide describes model_for
and the git-ignored .env instead of the old getpass flow; deck 4 rounds
the delegation cap to ~4,300 and explains why the runaway demo stays on
the stand-in. Slide counts unchanged (20/19/20/19).

Co-Authored-By: Claude Fable 5.1 <noreply@anthropic.com>
</commit_message>
<xml_diff>
--- a/presentations/m5-session-1-from-prompts-to-harnesses.pptx
+++ b/presentations/m5-session-1-from-prompts-to-harnesses.pptx
@@ -871,7 +871,7 @@
           <a:lstStyle/>
           <a:p>
             <a:r>
-              <a:t>Run the three cells live if you can. The same model answers all three times; the only thing that changes is what surrounds it. Better words do not add facts the model does not have - the prompt-engineered version is more polite and equally wrong. The harness adds a library, a way to search it, and a check before answering. Class question: what would you have to add to the prompt to make the bare model right, and would that scale to the next question?</a:t>
+              <a:t>Run the three cells live if you can. The same model answers all three times; the only thing that changes is what surrounds it. Better words do not add facts the model does not have - the prompt-engineered version is more polite and equally wrong. The harness adds a library, a way to search it, and a check before answering. The first three rows are the reference run on the stand-in, so the numbers are exact; the fourth row is the live demo on claude-opus-5 with a 2026 fact no model can know from training, and its wording changes every run. Class question: what would you have to add to the prompt to make the bare model right, and would that scale to the next question?</a:t>
             </a:r>
           </a:p>
         </p:txBody>
@@ -1011,7 +1011,7 @@
           <a:lstStyle/>
           <a:p>
             <a:r>
-              <a:t>This picture is what every harness produces if you ask it to. Read it as a story: the model did not know the date, so it searched; it found a document, so it read it; it drafted an answer and had it checked; the check passed, so it answered. The trace is also where debugging happens in Session 3. Class question: where in this trace would a wrong answer have been caught?</a:t>
+              <a:t>This picture is what every harness produces if you ask it to. Read it as a story: the model did not know the date, so it searched; it found a document, so it read it; it drafted an answer and had it checked; the check passed, so it answered. The trace is also where debugging happens in Session 3. On live Claude the trace has the same shape but the number of calls and the tokens differ from run to run. Class question: where in this trace would a wrong answer have been caught?</a:t>
             </a:r>
           </a:p>
         </p:txBody>
@@ -1081,7 +1081,7 @@
           <a:lstStyle/>
           <a:p>
             <a:r>
-              <a:t>Nothing is free. Every tool result is pasted into the context and the model reads it again on the next call. That is why Session 2 spends time on token-efficient tools and on compaction. Anthropic reported that its multi-agent research system used about 15 times the tokens of a chat, and accepted the bill because the task was worth it. Class question: for which questions would you refuse to pay 76x?</a:t>
+              <a:t>Nothing is free. Every tool result is pasted into the context and the model reads it again on the next call. That is why Session 2 spends time on token-efficient tools and on compaction. Anthropic reported that its multi-agent research system used about 15 times the tokens of a chat, and accepted the bill because the task was worth it. The live Claude run prints real usage from the API instead of the estimate. Class question: for which questions would you refuse to pay 76x?</a:t>
             </a:r>
           </a:p>
         </p:txBody>
@@ -1361,7 +1361,7 @@
           <a:lstStyle/>
           <a:p>
             <a:r>
-              <a:t>Recap the seven lines, then point at the exercises at the end of notebook 01: they extend the 15-line loop. Next session opens the four pieces the model sees: models, context, tools and skills. Class question to close: which of the eight pieces did notebook 01's harness NOT have, and what could go wrong because of it?</a:t>
+              <a:t>Recap the seven lines. The last one is the course mechanics: with an ANTHROPIC_API_KEY in a git-ignored .env the notebooks run on real Claude; without one they run on the deterministic stand-in, which is where every number on these slides comes from. Then point at the exercises at the end of notebook 01: they extend the 15-line loop. Next session opens the four pieces the model sees: models, context, tools and skills. Class question to close: which of the eight pieces did notebook 01's harness NOT have, and what could go wrong because of it?</a:t>
             </a:r>
           </a:p>
         </p:txBody>
@@ -7345,7 +7345,7 @@
                           </a:solidFill>
                           <a:latin typeface="Arial"/>
                         </a:rPr>
-                        <a:t>ScriptedModel in notebook 01 - no API key needed</a:t>
+                        <a:t>model_for('research'): Claude with a key in .env, the stand-in without</a:t>
                       </a:r>
                     </a:p>
                   </a:txBody>
@@ -8412,7 +8412,7 @@
         </p:nvGraphicFramePr>
         <p:xfrm>
           <a:off x="548640" y="1874519"/>
-          <a:ext cx="11091670" cy="1828800"/>
+          <a:ext cx="11091670" cy="2286000"/>
         </p:xfrm>
         <a:graphic>
           <a:graphicData uri="http://schemas.openxmlformats.org/drawingml/2006/table">
@@ -8882,6 +8882,120 @@
                   </a:tcPr>
                 </a:tc>
               </a:tr>
+              <a:tr h="457200">
+                <a:tc>
+                  <a:txBody>
+                    <a:bodyPr wrap="square"/>
+                    <a:lstStyle/>
+                    <a:p>
+                      <a:pPr algn="l">
+                        <a:spcAft>
+                          <a:spcPts val="0"/>
+                        </a:spcAft>
+                        <a:buNone/>
+                      </a:pPr>
+                      <a:r>
+                        <a:rPr sz="1250" b="0">
+                          <a:solidFill>
+                            <a:srgbClr val="202B38"/>
+                          </a:solidFill>
+                          <a:latin typeface="Arial"/>
+                        </a:rPr>
+                        <a:t>Live demo (claude-opus-5)</a:t>
+                      </a:r>
+                    </a:p>
+                  </a:txBody>
+                  <a:tcPr>
+                    <a:solidFill>
+                      <a:srgbClr val="EEF3FD"/>
+                    </a:solidFill>
+                  </a:tcPr>
+                </a:tc>
+                <a:tc>
+                  <a:txBody>
+                    <a:bodyPr wrap="square"/>
+                    <a:lstStyle/>
+                    <a:p>
+                      <a:pPr algn="l">
+                        <a:spcAft>
+                          <a:spcPts val="0"/>
+                        </a:spcAft>
+                        <a:buNone/>
+                      </a:pPr>
+                      <a:r>
+                        <a:rPr sz="1250" b="0">
+                          <a:solidFill>
+                            <a:srgbClr val="202B38"/>
+                          </a:solidFill>
+                          <a:latin typeface="Arial"/>
+                        </a:rPr>
+                        <a:t>A 2026 question no model knows from training: what share of security rules in instruction files is backed by a real control?</a:t>
+                      </a:r>
+                    </a:p>
+                  </a:txBody>
+                  <a:tcPr>
+                    <a:solidFill>
+                      <a:srgbClr val="EEF3FD"/>
+                    </a:solidFill>
+                  </a:tcPr>
+                </a:tc>
+                <a:tc>
+                  <a:txBody>
+                    <a:bodyPr wrap="square"/>
+                    <a:lstStyle/>
+                    <a:p>
+                      <a:pPr algn="l">
+                        <a:spcAft>
+                          <a:spcPts val="0"/>
+                        </a:spcAft>
+                        <a:buNone/>
+                      </a:pPr>
+                      <a:r>
+                        <a:rPr sz="1250" b="0">
+                          <a:solidFill>
+                            <a:srgbClr val="202B38"/>
+                          </a:solidFill>
+                          <a:latin typeface="Arial"/>
+                        </a:rPr>
+                        <a:t>'4.4% ...' with a [source: id] citation - wording varies run to run</a:t>
+                      </a:r>
+                    </a:p>
+                  </a:txBody>
+                  <a:tcPr>
+                    <a:solidFill>
+                      <a:srgbClr val="EEF3FD"/>
+                    </a:solidFill>
+                  </a:tcPr>
+                </a:tc>
+                <a:tc>
+                  <a:txBody>
+                    <a:bodyPr wrap="square"/>
+                    <a:lstStyle/>
+                    <a:p>
+                      <a:pPr algn="l">
+                        <a:spcAft>
+                          <a:spcPts val="0"/>
+                        </a:spcAft>
+                        <a:buNone/>
+                      </a:pPr>
+                      <a:r>
+                        <a:rPr sz="1250" b="0">
+                          <a:solidFill>
+                            <a:srgbClr val="202B38"/>
+                          </a:solidFill>
+                          <a:latin typeface="Arial"/>
+                        </a:rPr>
+                        <a:t>Real Claude, real tokens; the harness supplies the fact</a:t>
+                      </a:r>
+                    </a:p>
+                  </a:txBody>
+                  <a:tcPr>
+                    <a:solidFill>
+                      <a:srgbClr val="EEF3FD"/>
+                    </a:solidFill>
+                  </a:tcPr>
+                </a:tc>
+              </a:tr>
             </a:tbl>
           </a:graphicData>
         </a:graphic>
@@ -8921,7 +9035,7 @@
                 </a:solidFill>
                 <a:latin typeface="Arial"/>
               </a:rPr>
-              <a:t>The question: 'When did Anthropic open-source the Model Context Protocol, and which company adopted it in March 2025?' Same ScriptedModel in all three runs.</a:t>
+              <a:t>Rows 1-3: reference run on the deterministic stand-in; the live run on Claude varies and reports real tokens. Row 4: the notebook's live demo (Marmelab, Sep 2026 figure).</a:t>
             </a:r>
           </a:p>
         </p:txBody>
@@ -10272,7 +10386,7 @@
                 </a:solidFill>
                 <a:latin typeface="Arial"/>
               </a:rPr>
-              <a:t>Steps and counts from notebook 01 (4 model calls, 3 tool calls, ~1,980 estimated tokens). The estimate counts characters; a real API reports exact tokens.</a:t>
+              <a:t>Reference run on the deterministic stand-in (4 model calls, 3 tool calls, ~1,980 estimated tokens); the live run on Claude varies and reports real tokens.</a:t>
             </a:r>
           </a:p>
         </p:txBody>
@@ -10789,7 +10903,7 @@
                 </a:solidFill>
                 <a:latin typeface="Arial"/>
               </a:rPr>
-              <a:t>Estimated tokens from notebook 01 (character-based estimate, deterministic ScriptedModel). Anthropic's research system ran at ~15x a chat's tokens (Jun 2025).</a:t>
+              <a:t>Reference run on the deterministic stand-in; the live run on Claude varies and reports real tokens. Anthropic's research system ran at ~15x a chat's tokens (Jun 2025).</a:t>
             </a:r>
           </a:p>
         </p:txBody>
@@ -11687,7 +11801,7 @@
                 </a:solidFill>
                 <a:latin typeface="Arial"/>
               </a:rPr>
-              <a:t>How to read it: left, the loop notebook 01 writes inline; right, what each line does. Anthropic, Claude Agent SDK, Sep 2025: gather context, act, verify, repeat.</a:t>
+              <a:t>How to read it: left, the loop notebook 01 writes inline (same loop for the stand-in and for Claude); right, what each line does. Anthropic, Claude Agent SDK, Sep 2025.</a:t>
             </a:r>
           </a:p>
         </p:txBody>
@@ -12117,7 +12231,7 @@
                 </a:solidFill>
                 <a:latin typeface="Arial"/>
               </a:rPr>
-              <a:t>arXiv 2605.23950, May 2026; arXiv 2609.11987, Sep 2026. Our notebook shows the same effect at toy scale: one ScriptedModel, a wrong answer without a harness and a cited one with it.</a:t>
+              <a:t>arXiv 2605.23950, May 2026; arXiv 2609.11987, Sep 2026. Our notebook shows the same effect at toy scale: the stand-in reference run is wrong without a harness and cited with it; the live Claude run varies and reports real tokens.</a:t>
             </a:r>
           </a:p>
         </p:txBody>
@@ -12724,7 +12838,7 @@
                 </a:solidFill>
                 <a:latin typeface="Arial"/>
               </a:rPr>
-              <a:t>Practice now, zero setup: notebook 01 in Colab, Runtime &gt; Run all, then the exercises before the solutions</a:t>
+              <a:t>Two engines, one harness: model_for(role) returns Claude when a key is present, the stand-in otherwise - notebook 01 runs either way</a:t>
             </a:r>
           </a:p>
         </p:txBody>

</xml_diff>